<commit_message>
Phase 4.5 complete notebook QA and release
Co-authored-by: Cursor <cursoragent@cursor.com>
</commit_message>
<xml_diff>
--- a/production/releases/chapter-01/01-ch1-energy-causes-change-slides.pptx
+++ b/production/releases/chapter-01/01-ch1-energy-causes-change-slides.pptx
@@ -11,7 +11,9 @@
     <p:sldId id="259" r:id="rId10"/>
     <p:sldId id="260" r:id="rId11"/>
     <p:sldId id="261" r:id="rId12"/>
+    <p:sldId id="278" r:id="rId29"/>
     <p:sldId id="262" r:id="rId13"/>
+    <p:sldId id="279" r:id="rId30"/>
     <p:sldId id="263" r:id="rId14"/>
     <p:sldId id="264" r:id="rId15"/>
     <p:sldId id="265" r:id="rId16"/>
@@ -24,6 +26,7 @@
     <p:sldId id="272" r:id="rId23"/>
     <p:sldId id="273" r:id="rId24"/>
     <p:sldId id="274" r:id="rId25"/>
+    <p:sldId id="280" r:id="rId31"/>
     <p:sldId id="275" r:id="rId26"/>
     <p:sldId id="276" r:id="rId27"/>
     <p:sldId id="277" r:id="rId28"/>
@@ -7977,6 +7980,1408 @@
                 <a:latin typeface="Arial"/>
               </a:rPr>
               <a:t>22</a:t>
+            </a:r>
+          </a:p>
+        </p:txBody>
+      </p:sp>
+    </p:spTree>
+  </p:cSld>
+  <p:clrMapOvr>
+    <a:masterClrMapping/>
+  </p:clrMapOvr>
+</p:sld>
+</file>
+
+<file path=ppt/slides/slide23.xml><?xml version="1.0" encoding="utf-8"?>
+<p:sld xmlns:a="http://schemas.openxmlformats.org/drawingml/2006/main" xmlns:p="http://schemas.openxmlformats.org/presentationml/2006/main" xmlns:r="http://schemas.openxmlformats.org/officeDocument/2006/relationships">
+  <p:cSld>
+    <p:spTree>
+      <p:nvGrpSpPr>
+        <p:cNvPr id="1" name=""/>
+        <p:cNvGrpSpPr/>
+        <p:nvPr/>
+      </p:nvGrpSpPr>
+      <p:grpSpPr/>
+      <p:sp>
+        <p:nvSpPr>
+          <p:cNvPr id="2" name="Rounded Rectangle 1"/>
+          <p:cNvSpPr/>
+          <p:nvPr/>
+        </p:nvSpPr>
+        <p:spPr>
+          <a:xfrm>
+            <a:off x="0" y="0"/>
+            <a:ext cx="12191695" cy="1051560"/>
+          </a:xfrm>
+          <a:prstGeom prst="roundRect">
+            <a:avLst/>
+          </a:prstGeom>
+          <a:solidFill>
+            <a:srgbClr val="1F3A5F"/>
+          </a:solidFill>
+          <a:ln>
+            <a:noFill/>
+          </a:ln>
+        </p:spPr>
+        <p:style>
+          <a:lnRef idx="1">
+            <a:schemeClr val="accent1"/>
+          </a:lnRef>
+          <a:fillRef idx="3">
+            <a:schemeClr val="accent1"/>
+          </a:fillRef>
+          <a:effectRef idx="2">
+            <a:schemeClr val="accent1"/>
+          </a:effectRef>
+          <a:fontRef idx="minor">
+            <a:schemeClr val="lt1"/>
+          </a:fontRef>
+        </p:style>
+        <p:txBody>
+          <a:bodyPr rtlCol="0" anchor="ctr" wrap="square"/>
+          <a:lstStyle/>
+          <a:p>
+            <a:pPr algn="ctr"/>
+          </a:p>
+        </p:txBody>
+      </p:sp>
+      <p:sp>
+        <p:nvSpPr>
+          <p:cNvPr id="3" name="TextBox 2"/>
+          <p:cNvSpPr txBox="1"/>
+          <p:nvPr/>
+        </p:nvSpPr>
+        <p:spPr>
+          <a:xfrm>
+            <a:off x="457200" y="146304"/>
+            <a:ext cx="10058400" cy="777240"/>
+          </a:xfrm>
+          <a:prstGeom prst="rect">
+            <a:avLst/>
+          </a:prstGeom>
+          <a:noFill/>
+        </p:spPr>
+        <p:txBody>
+          <a:bodyPr wrap="square" anchor="ctr">
+            <a:spAutoFit/>
+          </a:bodyPr>
+          <a:lstStyle/>
+          <a:p>
+            <a:pPr algn="l"/>
+            <a:r>
+              <a:rPr sz="3400" b="1" i="0">
+                <a:solidFill>
+                  <a:srgbClr val="FFFFFF"/>
+                </a:solidFill>
+                <a:latin typeface="Arial"/>
+              </a:rPr>
+              <a:t>Notebook — Energy</a:t>
+            </a:r>
+          </a:p>
+        </p:txBody>
+      </p:sp>
+      <p:sp>
+        <p:nvSpPr>
+          <p:cNvPr id="4" name="Rounded Rectangle 3"/>
+          <p:cNvSpPr/>
+          <p:nvPr/>
+        </p:nvSpPr>
+        <p:spPr>
+          <a:xfrm>
+            <a:off x="9692640" y="256032"/>
+            <a:ext cx="2103120" cy="548640"/>
+          </a:xfrm>
+          <a:prstGeom prst="roundRect">
+            <a:avLst/>
+          </a:prstGeom>
+          <a:solidFill>
+            <a:srgbClr val="C05014"/>
+          </a:solidFill>
+          <a:ln>
+            <a:noFill/>
+          </a:ln>
+        </p:spPr>
+        <p:style>
+          <a:lnRef idx="1">
+            <a:schemeClr val="accent1"/>
+          </a:lnRef>
+          <a:fillRef idx="3">
+            <a:schemeClr val="accent1"/>
+          </a:fillRef>
+          <a:effectRef idx="2">
+            <a:schemeClr val="accent1"/>
+          </a:effectRef>
+          <a:fontRef idx="minor">
+            <a:schemeClr val="lt1"/>
+          </a:fontRef>
+        </p:style>
+        <p:txBody>
+          <a:bodyPr rtlCol="0" anchor="ctr" wrap="square"/>
+          <a:lstStyle/>
+          <a:p>
+            <a:pPr algn="ctr"/>
+            <a:r>
+              <a:rPr sz="1800" b="1">
+                <a:solidFill>
+                  <a:srgbClr val="FFFFFF"/>
+                </a:solidFill>
+                <a:latin typeface="Arial"/>
+              </a:rPr>
+              <a:t>NOTEBOOK</a:t>
+            </a:r>
+          </a:p>
+        </p:txBody>
+      </p:sp>
+      <p:sp>
+        <p:nvSpPr>
+          <p:cNvPr id="5" name="Rounded Rectangle 4"/>
+          <p:cNvSpPr/>
+          <p:nvPr/>
+        </p:nvSpPr>
+        <p:spPr>
+          <a:xfrm>
+            <a:off x="1097280" y="1737360"/>
+            <a:ext cx="9966960" cy="1234440"/>
+          </a:xfrm>
+          <a:prstGeom prst="roundRect">
+            <a:avLst/>
+          </a:prstGeom>
+          <a:solidFill>
+            <a:srgbClr val="E8EDF4"/>
+          </a:solidFill>
+          <a:ln>
+            <a:noFill/>
+          </a:ln>
+        </p:spPr>
+        <p:style>
+          <a:lnRef idx="1">
+            <a:schemeClr val="accent1"/>
+          </a:lnRef>
+          <a:fillRef idx="3">
+            <a:schemeClr val="accent1"/>
+          </a:fillRef>
+          <a:effectRef idx="2">
+            <a:schemeClr val="accent1"/>
+          </a:effectRef>
+          <a:fontRef idx="minor">
+            <a:schemeClr val="lt1"/>
+          </a:fontRef>
+        </p:style>
+        <p:txBody>
+          <a:bodyPr rtlCol="0" anchor="ctr" wrap="square"/>
+          <a:lstStyle/>
+          <a:p>
+            <a:pPr algn="ctr"/>
+          </a:p>
+        </p:txBody>
+      </p:sp>
+      <p:sp>
+        <p:nvSpPr>
+          <p:cNvPr id="6" name="TextBox 5"/>
+          <p:cNvSpPr txBox="1"/>
+          <p:nvPr/>
+        </p:nvSpPr>
+        <p:spPr>
+          <a:xfrm>
+            <a:off x="1371600" y="1828800"/>
+            <a:ext cx="9418320" cy="457200"/>
+          </a:xfrm>
+          <a:prstGeom prst="rect">
+            <a:avLst/>
+          </a:prstGeom>
+          <a:noFill/>
+        </p:spPr>
+        <p:txBody>
+          <a:bodyPr wrap="square" anchor="t">
+            <a:spAutoFit/>
+          </a:bodyPr>
+          <a:lstStyle/>
+          <a:p>
+            <a:pPr algn="l"/>
+            <a:r>
+              <a:rPr sz="1600" b="1" i="0">
+                <a:solidFill>
+                  <a:srgbClr val="C05014"/>
+                </a:solidFill>
+                <a:latin typeface="Arial"/>
+              </a:rPr>
+              <a:t>WRITE:</a:t>
+            </a:r>
+          </a:p>
+        </p:txBody>
+      </p:sp>
+      <p:sp>
+        <p:nvSpPr>
+          <p:cNvPr id="7" name="TextBox 6"/>
+          <p:cNvSpPr txBox="1"/>
+          <p:nvPr/>
+        </p:nvSpPr>
+        <p:spPr>
+          <a:xfrm>
+            <a:off x="1371600" y="2240280"/>
+            <a:ext cx="9418320" cy="640080"/>
+          </a:xfrm>
+          <a:prstGeom prst="rect">
+            <a:avLst/>
+          </a:prstGeom>
+          <a:noFill/>
+        </p:spPr>
+        <p:txBody>
+          <a:bodyPr wrap="square" anchor="t">
+            <a:spAutoFit/>
+          </a:bodyPr>
+          <a:lstStyle/>
+          <a:p>
+            <a:pPr algn="l"/>
+            <a:r>
+              <a:rPr sz="2800" b="1" i="0">
+                <a:solidFill>
+                  <a:srgbClr val="1F3A5F"/>
+                </a:solidFill>
+                <a:latin typeface="Arial"/>
+              </a:rPr>
+              <a:t>Energy is the ability to cause change.</a:t>
+            </a:r>
+          </a:p>
+        </p:txBody>
+      </p:sp>
+      <p:sp>
+        <p:nvSpPr>
+          <p:cNvPr id="8" name="TextBox 7"/>
+          <p:cNvSpPr txBox="1"/>
+          <p:nvPr/>
+        </p:nvSpPr>
+        <p:spPr>
+          <a:xfrm>
+            <a:off x="1371600" y="3017520"/>
+            <a:ext cx="9418320" cy="457200"/>
+          </a:xfrm>
+          <a:prstGeom prst="rect">
+            <a:avLst/>
+          </a:prstGeom>
+          <a:noFill/>
+        </p:spPr>
+        <p:txBody>
+          <a:bodyPr wrap="square" anchor="t">
+            <a:spAutoFit/>
+          </a:bodyPr>
+          <a:lstStyle/>
+          <a:p>
+            <a:pPr algn="l"/>
+            <a:r>
+              <a:rPr sz="1600" b="0" i="1">
+                <a:solidFill>
+                  <a:srgbClr val="555555"/>
+                </a:solidFill>
+                <a:latin typeface="Arial"/>
+              </a:rPr>
+              <a:t>REVEAL → CHANGE</a:t>
+            </a:r>
+          </a:p>
+        </p:txBody>
+      </p:sp>
+      <p:sp>
+        <p:nvSpPr>
+          <p:cNvPr id="9" name="Rounded Rectangle 8"/>
+          <p:cNvSpPr/>
+          <p:nvPr/>
+        </p:nvSpPr>
+        <p:spPr>
+          <a:xfrm>
+            <a:off x="1097280" y="4206240"/>
+            <a:ext cx="9966960" cy="1828800"/>
+          </a:xfrm>
+          <a:prstGeom prst="roundRect">
+            <a:avLst/>
+          </a:prstGeom>
+          <a:solidFill>
+            <a:srgbClr val="2E6B3F"/>
+          </a:solidFill>
+          <a:ln>
+            <a:noFill/>
+          </a:ln>
+        </p:spPr>
+        <p:style>
+          <a:lnRef idx="1">
+            <a:schemeClr val="accent1"/>
+          </a:lnRef>
+          <a:fillRef idx="3">
+            <a:schemeClr val="accent1"/>
+          </a:fillRef>
+          <a:effectRef idx="2">
+            <a:schemeClr val="accent1"/>
+          </a:effectRef>
+          <a:fontRef idx="minor">
+            <a:schemeClr val="lt1"/>
+          </a:fontRef>
+        </p:style>
+        <p:txBody>
+          <a:bodyPr rtlCol="0" anchor="ctr" wrap="square"/>
+          <a:lstStyle/>
+          <a:p>
+            <a:pPr algn="ctr"/>
+          </a:p>
+        </p:txBody>
+      </p:sp>
+      <p:sp>
+        <p:nvSpPr>
+          <p:cNvPr id="10" name="TextBox 9"/>
+          <p:cNvSpPr txBox="1"/>
+          <p:nvPr/>
+        </p:nvSpPr>
+        <p:spPr>
+          <a:xfrm>
+            <a:off x="1371600" y="4297679"/>
+            <a:ext cx="9418320" cy="457200"/>
+          </a:xfrm>
+          <a:prstGeom prst="rect">
+            <a:avLst/>
+          </a:prstGeom>
+          <a:noFill/>
+        </p:spPr>
+        <p:txBody>
+          <a:bodyPr wrap="square" anchor="t">
+            <a:spAutoFit/>
+          </a:bodyPr>
+          <a:lstStyle/>
+          <a:p>
+            <a:pPr algn="l"/>
+            <a:r>
+              <a:rPr sz="1600" b="1" i="0">
+                <a:solidFill>
+                  <a:srgbClr val="FFFFFF"/>
+                </a:solidFill>
+                <a:latin typeface="Arial"/>
+              </a:rPr>
+              <a:t>DRAWING IDEAS (draw YOUR example):</a:t>
+            </a:r>
+          </a:p>
+        </p:txBody>
+      </p:sp>
+      <p:sp>
+        <p:nvSpPr>
+          <p:cNvPr id="11" name="TextBox 10"/>
+          <p:cNvSpPr txBox="1"/>
+          <p:nvPr/>
+        </p:nvSpPr>
+        <p:spPr>
+          <a:xfrm>
+            <a:off x="1463040" y="4754879"/>
+            <a:ext cx="9418320" cy="411480"/>
+          </a:xfrm>
+          <a:prstGeom prst="rect">
+            <a:avLst/>
+          </a:prstGeom>
+          <a:noFill/>
+        </p:spPr>
+        <p:txBody>
+          <a:bodyPr wrap="square" anchor="t">
+            <a:spAutoFit/>
+          </a:bodyPr>
+          <a:lstStyle/>
+          <a:p>
+            <a:pPr algn="l"/>
+            <a:r>
+              <a:rPr sz="1800" b="0" i="0">
+                <a:solidFill>
+                  <a:srgbClr val="FFFFFF"/>
+                </a:solidFill>
+                <a:latin typeface="Arial"/>
+              </a:rPr>
+              <a:t>•  a flashlight turning on</a:t>
+            </a:r>
+          </a:p>
+        </p:txBody>
+      </p:sp>
+      <p:sp>
+        <p:nvSpPr>
+          <p:cNvPr id="12" name="TextBox 11"/>
+          <p:cNvSpPr txBox="1"/>
+          <p:nvPr/>
+        </p:nvSpPr>
+        <p:spPr>
+          <a:xfrm>
+            <a:off x="1463040" y="5166359"/>
+            <a:ext cx="9418320" cy="411480"/>
+          </a:xfrm>
+          <a:prstGeom prst="rect">
+            <a:avLst/>
+          </a:prstGeom>
+          <a:noFill/>
+        </p:spPr>
+        <p:txBody>
+          <a:bodyPr wrap="square" anchor="t">
+            <a:spAutoFit/>
+          </a:bodyPr>
+          <a:lstStyle/>
+          <a:p>
+            <a:pPr algn="l"/>
+            <a:r>
+              <a:rPr sz="1800" b="0" i="0">
+                <a:solidFill>
+                  <a:srgbClr val="FFFFFF"/>
+                </a:solidFill>
+                <a:latin typeface="Arial"/>
+              </a:rPr>
+              <a:t>•  a rolling ball moving a cup</a:t>
+            </a:r>
+          </a:p>
+        </p:txBody>
+      </p:sp>
+      <p:sp>
+        <p:nvSpPr>
+          <p:cNvPr id="13" name="TextBox 12"/>
+          <p:cNvSpPr txBox="1"/>
+          <p:nvPr/>
+        </p:nvSpPr>
+        <p:spPr>
+          <a:xfrm>
+            <a:off x="1463040" y="5577840"/>
+            <a:ext cx="9418320" cy="411480"/>
+          </a:xfrm>
+          <a:prstGeom prst="rect">
+            <a:avLst/>
+          </a:prstGeom>
+          <a:noFill/>
+        </p:spPr>
+        <p:txBody>
+          <a:bodyPr wrap="square" anchor="t">
+            <a:spAutoFit/>
+          </a:bodyPr>
+          <a:lstStyle/>
+          <a:p>
+            <a:pPr algn="l"/>
+            <a:r>
+              <a:rPr sz="1800" b="0" i="0">
+                <a:solidFill>
+                  <a:srgbClr val="FFFFFF"/>
+                </a:solidFill>
+                <a:latin typeface="Arial"/>
+              </a:rPr>
+              <a:t>•  a ringing bell</a:t>
+            </a:r>
+          </a:p>
+        </p:txBody>
+      </p:sp>
+    </p:spTree>
+  </p:cSld>
+  <p:clrMapOvr>
+    <a:masterClrMapping/>
+  </p:clrMapOvr>
+</p:sld>
+</file>
+
+<file path=ppt/slides/slide24.xml><?xml version="1.0" encoding="utf-8"?>
+<p:sld xmlns:a="http://schemas.openxmlformats.org/drawingml/2006/main" xmlns:p="http://schemas.openxmlformats.org/presentationml/2006/main" xmlns:r="http://schemas.openxmlformats.org/officeDocument/2006/relationships">
+  <p:cSld>
+    <p:spTree>
+      <p:nvGrpSpPr>
+        <p:cNvPr id="1" name=""/>
+        <p:cNvGrpSpPr/>
+        <p:nvPr/>
+      </p:nvGrpSpPr>
+      <p:grpSpPr/>
+      <p:sp>
+        <p:nvSpPr>
+          <p:cNvPr id="2" name="Rounded Rectangle 1"/>
+          <p:cNvSpPr/>
+          <p:nvPr/>
+        </p:nvSpPr>
+        <p:spPr>
+          <a:xfrm>
+            <a:off x="0" y="0"/>
+            <a:ext cx="12191695" cy="1051560"/>
+          </a:xfrm>
+          <a:prstGeom prst="roundRect">
+            <a:avLst/>
+          </a:prstGeom>
+          <a:solidFill>
+            <a:srgbClr val="1F3A5F"/>
+          </a:solidFill>
+          <a:ln>
+            <a:noFill/>
+          </a:ln>
+        </p:spPr>
+        <p:style>
+          <a:lnRef idx="1">
+            <a:schemeClr val="accent1"/>
+          </a:lnRef>
+          <a:fillRef idx="3">
+            <a:schemeClr val="accent1"/>
+          </a:fillRef>
+          <a:effectRef idx="2">
+            <a:schemeClr val="accent1"/>
+          </a:effectRef>
+          <a:fontRef idx="minor">
+            <a:schemeClr val="lt1"/>
+          </a:fontRef>
+        </p:style>
+        <p:txBody>
+          <a:bodyPr rtlCol="0" anchor="ctr" wrap="square"/>
+          <a:lstStyle/>
+          <a:p>
+            <a:pPr algn="ctr"/>
+          </a:p>
+        </p:txBody>
+      </p:sp>
+      <p:sp>
+        <p:nvSpPr>
+          <p:cNvPr id="3" name="TextBox 2"/>
+          <p:cNvSpPr txBox="1"/>
+          <p:nvPr/>
+        </p:nvSpPr>
+        <p:spPr>
+          <a:xfrm>
+            <a:off x="457200" y="146304"/>
+            <a:ext cx="10058400" cy="777240"/>
+          </a:xfrm>
+          <a:prstGeom prst="rect">
+            <a:avLst/>
+          </a:prstGeom>
+          <a:noFill/>
+        </p:spPr>
+        <p:txBody>
+          <a:bodyPr wrap="square" anchor="ctr">
+            <a:spAutoFit/>
+          </a:bodyPr>
+          <a:lstStyle/>
+          <a:p>
+            <a:pPr algn="l"/>
+            <a:r>
+              <a:rPr sz="3400" b="1" i="0">
+                <a:solidFill>
+                  <a:srgbClr val="FFFFFF"/>
+                </a:solidFill>
+                <a:latin typeface="Arial"/>
+              </a:rPr>
+              <a:t>Notebook — Energy Model</a:t>
+            </a:r>
+          </a:p>
+        </p:txBody>
+      </p:sp>
+      <p:sp>
+        <p:nvSpPr>
+          <p:cNvPr id="4" name="Rounded Rectangle 3"/>
+          <p:cNvSpPr/>
+          <p:nvPr/>
+        </p:nvSpPr>
+        <p:spPr>
+          <a:xfrm>
+            <a:off x="9692640" y="256032"/>
+            <a:ext cx="2103120" cy="548640"/>
+          </a:xfrm>
+          <a:prstGeom prst="roundRect">
+            <a:avLst/>
+          </a:prstGeom>
+          <a:solidFill>
+            <a:srgbClr val="C05014"/>
+          </a:solidFill>
+          <a:ln>
+            <a:noFill/>
+          </a:ln>
+        </p:spPr>
+        <p:style>
+          <a:lnRef idx="1">
+            <a:schemeClr val="accent1"/>
+          </a:lnRef>
+          <a:fillRef idx="3">
+            <a:schemeClr val="accent1"/>
+          </a:fillRef>
+          <a:effectRef idx="2">
+            <a:schemeClr val="accent1"/>
+          </a:effectRef>
+          <a:fontRef idx="minor">
+            <a:schemeClr val="lt1"/>
+          </a:fontRef>
+        </p:style>
+        <p:txBody>
+          <a:bodyPr rtlCol="0" anchor="ctr" wrap="square"/>
+          <a:lstStyle/>
+          <a:p>
+            <a:pPr algn="ctr"/>
+            <a:r>
+              <a:rPr sz="1800" b="1">
+                <a:solidFill>
+                  <a:srgbClr val="FFFFFF"/>
+                </a:solidFill>
+                <a:latin typeface="Arial"/>
+              </a:rPr>
+              <a:t>NOTEBOOK</a:t>
+            </a:r>
+          </a:p>
+        </p:txBody>
+      </p:sp>
+      <p:sp>
+        <p:nvSpPr>
+          <p:cNvPr id="5" name="Rounded Rectangle 4"/>
+          <p:cNvSpPr/>
+          <p:nvPr/>
+        </p:nvSpPr>
+        <p:spPr>
+          <a:xfrm>
+            <a:off x="1097280" y="1737360"/>
+            <a:ext cx="9966960" cy="1234440"/>
+          </a:xfrm>
+          <a:prstGeom prst="roundRect">
+            <a:avLst/>
+          </a:prstGeom>
+          <a:solidFill>
+            <a:srgbClr val="E8EDF4"/>
+          </a:solidFill>
+          <a:ln>
+            <a:noFill/>
+          </a:ln>
+        </p:spPr>
+        <p:style>
+          <a:lnRef idx="1">
+            <a:schemeClr val="accent1"/>
+          </a:lnRef>
+          <a:fillRef idx="3">
+            <a:schemeClr val="accent1"/>
+          </a:fillRef>
+          <a:effectRef idx="2">
+            <a:schemeClr val="accent1"/>
+          </a:effectRef>
+          <a:fontRef idx="minor">
+            <a:schemeClr val="lt1"/>
+          </a:fontRef>
+        </p:style>
+        <p:txBody>
+          <a:bodyPr rtlCol="0" anchor="ctr" wrap="square"/>
+          <a:lstStyle/>
+          <a:p>
+            <a:pPr algn="ctr"/>
+          </a:p>
+        </p:txBody>
+      </p:sp>
+      <p:sp>
+        <p:nvSpPr>
+          <p:cNvPr id="6" name="TextBox 5"/>
+          <p:cNvSpPr txBox="1"/>
+          <p:nvPr/>
+        </p:nvSpPr>
+        <p:spPr>
+          <a:xfrm>
+            <a:off x="1371600" y="1828800"/>
+            <a:ext cx="9418320" cy="457200"/>
+          </a:xfrm>
+          <a:prstGeom prst="rect">
+            <a:avLst/>
+          </a:prstGeom>
+          <a:noFill/>
+        </p:spPr>
+        <p:txBody>
+          <a:bodyPr wrap="square" anchor="t">
+            <a:spAutoFit/>
+          </a:bodyPr>
+          <a:lstStyle/>
+          <a:p>
+            <a:pPr algn="l"/>
+            <a:r>
+              <a:rPr sz="1600" b="1" i="0">
+                <a:solidFill>
+                  <a:srgbClr val="C05014"/>
+                </a:solidFill>
+                <a:latin typeface="Arial"/>
+              </a:rPr>
+              <a:t>WRITE:</a:t>
+            </a:r>
+          </a:p>
+        </p:txBody>
+      </p:sp>
+      <p:sp>
+        <p:nvSpPr>
+          <p:cNvPr id="7" name="TextBox 6"/>
+          <p:cNvSpPr txBox="1"/>
+          <p:nvPr/>
+        </p:nvSpPr>
+        <p:spPr>
+          <a:xfrm>
+            <a:off x="1371600" y="2240280"/>
+            <a:ext cx="9418320" cy="640080"/>
+          </a:xfrm>
+          <a:prstGeom prst="rect">
+            <a:avLst/>
+          </a:prstGeom>
+          <a:noFill/>
+        </p:spPr>
+        <p:txBody>
+          <a:bodyPr wrap="square" anchor="t">
+            <a:spAutoFit/>
+          </a:bodyPr>
+          <a:lstStyle/>
+          <a:p>
+            <a:pPr algn="l"/>
+            <a:r>
+              <a:rPr sz="2800" b="1" i="0">
+                <a:solidFill>
+                  <a:srgbClr val="1F3A5F"/>
+                </a:solidFill>
+                <a:latin typeface="Arial"/>
+              </a:rPr>
+              <a:t>ENERGY  →  CHANGE  →  EVIDENCE</a:t>
+            </a:r>
+          </a:p>
+        </p:txBody>
+      </p:sp>
+      <p:sp>
+        <p:nvSpPr>
+          <p:cNvPr id="8" name="TextBox 7"/>
+          <p:cNvSpPr txBox="1"/>
+          <p:nvPr/>
+        </p:nvSpPr>
+        <p:spPr>
+          <a:xfrm>
+            <a:off x="1371600" y="3017520"/>
+            <a:ext cx="9418320" cy="457200"/>
+          </a:xfrm>
+          <a:prstGeom prst="rect">
+            <a:avLst/>
+          </a:prstGeom>
+          <a:noFill/>
+        </p:spPr>
+        <p:txBody>
+          <a:bodyPr wrap="square" anchor="t">
+            <a:spAutoFit/>
+          </a:bodyPr>
+          <a:lstStyle/>
+          <a:p>
+            <a:pPr algn="l"/>
+            <a:r>
+              <a:rPr sz="1600" b="0" i="1">
+                <a:solidFill>
+                  <a:srgbClr val="555555"/>
+                </a:solidFill>
+                <a:latin typeface="Arial"/>
+              </a:rPr>
+              <a:t>REVEAL → the chain</a:t>
+            </a:r>
+          </a:p>
+        </p:txBody>
+      </p:sp>
+      <p:sp>
+        <p:nvSpPr>
+          <p:cNvPr id="9" name="Rounded Rectangle 8"/>
+          <p:cNvSpPr/>
+          <p:nvPr/>
+        </p:nvSpPr>
+        <p:spPr>
+          <a:xfrm>
+            <a:off x="1097280" y="4206240"/>
+            <a:ext cx="9966960" cy="1828800"/>
+          </a:xfrm>
+          <a:prstGeom prst="roundRect">
+            <a:avLst/>
+          </a:prstGeom>
+          <a:solidFill>
+            <a:srgbClr val="2E6B3F"/>
+          </a:solidFill>
+          <a:ln>
+            <a:noFill/>
+          </a:ln>
+        </p:spPr>
+        <p:style>
+          <a:lnRef idx="1">
+            <a:schemeClr val="accent1"/>
+          </a:lnRef>
+          <a:fillRef idx="3">
+            <a:schemeClr val="accent1"/>
+          </a:fillRef>
+          <a:effectRef idx="2">
+            <a:schemeClr val="accent1"/>
+          </a:effectRef>
+          <a:fontRef idx="minor">
+            <a:schemeClr val="lt1"/>
+          </a:fontRef>
+        </p:style>
+        <p:txBody>
+          <a:bodyPr rtlCol="0" anchor="ctr" wrap="square"/>
+          <a:lstStyle/>
+          <a:p>
+            <a:pPr algn="ctr"/>
+          </a:p>
+        </p:txBody>
+      </p:sp>
+      <p:sp>
+        <p:nvSpPr>
+          <p:cNvPr id="10" name="TextBox 9"/>
+          <p:cNvSpPr txBox="1"/>
+          <p:nvPr/>
+        </p:nvSpPr>
+        <p:spPr>
+          <a:xfrm>
+            <a:off x="1371600" y="4297679"/>
+            <a:ext cx="9418320" cy="457200"/>
+          </a:xfrm>
+          <a:prstGeom prst="rect">
+            <a:avLst/>
+          </a:prstGeom>
+          <a:noFill/>
+        </p:spPr>
+        <p:txBody>
+          <a:bodyPr wrap="square" anchor="t">
+            <a:spAutoFit/>
+          </a:bodyPr>
+          <a:lstStyle/>
+          <a:p>
+            <a:pPr algn="l"/>
+            <a:r>
+              <a:rPr sz="1600" b="1" i="0">
+                <a:solidFill>
+                  <a:srgbClr val="FFFFFF"/>
+                </a:solidFill>
+                <a:latin typeface="Arial"/>
+              </a:rPr>
+              <a:t>DRAWING IDEAS (draw YOUR example):</a:t>
+            </a:r>
+          </a:p>
+        </p:txBody>
+      </p:sp>
+      <p:sp>
+        <p:nvSpPr>
+          <p:cNvPr id="11" name="TextBox 10"/>
+          <p:cNvSpPr txBox="1"/>
+          <p:nvPr/>
+        </p:nvSpPr>
+        <p:spPr>
+          <a:xfrm>
+            <a:off x="1463040" y="4754879"/>
+            <a:ext cx="9418320" cy="411480"/>
+          </a:xfrm>
+          <a:prstGeom prst="rect">
+            <a:avLst/>
+          </a:prstGeom>
+          <a:noFill/>
+        </p:spPr>
+        <p:txBody>
+          <a:bodyPr wrap="square" anchor="t">
+            <a:spAutoFit/>
+          </a:bodyPr>
+          <a:lstStyle/>
+          <a:p>
+            <a:pPr algn="l"/>
+            <a:r>
+              <a:rPr sz="1800" b="0" i="0">
+                <a:solidFill>
+                  <a:srgbClr val="FFFFFF"/>
+                </a:solidFill>
+                <a:latin typeface="Arial"/>
+              </a:rPr>
+              <a:t>•  draw a before/after example</a:t>
+            </a:r>
+          </a:p>
+        </p:txBody>
+      </p:sp>
+      <p:sp>
+        <p:nvSpPr>
+          <p:cNvPr id="12" name="TextBox 11"/>
+          <p:cNvSpPr txBox="1"/>
+          <p:nvPr/>
+        </p:nvSpPr>
+        <p:spPr>
+          <a:xfrm>
+            <a:off x="1463040" y="5166359"/>
+            <a:ext cx="9418320" cy="411480"/>
+          </a:xfrm>
+          <a:prstGeom prst="rect">
+            <a:avLst/>
+          </a:prstGeom>
+          <a:noFill/>
+        </p:spPr>
+        <p:txBody>
+          <a:bodyPr wrap="square" anchor="t">
+            <a:spAutoFit/>
+          </a:bodyPr>
+          <a:lstStyle/>
+          <a:p>
+            <a:pPr algn="l"/>
+            <a:r>
+              <a:rPr sz="1800" b="0" i="0">
+                <a:solidFill>
+                  <a:srgbClr val="FFFFFF"/>
+                </a:solidFill>
+                <a:latin typeface="Arial"/>
+              </a:rPr>
+              <a:t>•  add arrows to show the change</a:t>
+            </a:r>
+          </a:p>
+        </p:txBody>
+      </p:sp>
+    </p:spTree>
+  </p:cSld>
+  <p:clrMapOvr>
+    <a:masterClrMapping/>
+  </p:clrMapOvr>
+</p:sld>
+</file>
+
+<file path=ppt/slides/slide25.xml><?xml version="1.0" encoding="utf-8"?>
+<p:sld xmlns:a="http://schemas.openxmlformats.org/drawingml/2006/main" xmlns:p="http://schemas.openxmlformats.org/presentationml/2006/main" xmlns:r="http://schemas.openxmlformats.org/officeDocument/2006/relationships">
+  <p:cSld>
+    <p:spTree>
+      <p:nvGrpSpPr>
+        <p:cNvPr id="1" name=""/>
+        <p:cNvGrpSpPr/>
+        <p:nvPr/>
+      </p:nvGrpSpPr>
+      <p:grpSpPr/>
+      <p:sp>
+        <p:nvSpPr>
+          <p:cNvPr id="2" name="Rounded Rectangle 1"/>
+          <p:cNvSpPr/>
+          <p:nvPr/>
+        </p:nvSpPr>
+        <p:spPr>
+          <a:xfrm>
+            <a:off x="0" y="0"/>
+            <a:ext cx="12191695" cy="1051560"/>
+          </a:xfrm>
+          <a:prstGeom prst="roundRect">
+            <a:avLst/>
+          </a:prstGeom>
+          <a:solidFill>
+            <a:srgbClr val="1F3A5F"/>
+          </a:solidFill>
+          <a:ln>
+            <a:noFill/>
+          </a:ln>
+        </p:spPr>
+        <p:style>
+          <a:lnRef idx="1">
+            <a:schemeClr val="accent1"/>
+          </a:lnRef>
+          <a:fillRef idx="3">
+            <a:schemeClr val="accent1"/>
+          </a:fillRef>
+          <a:effectRef idx="2">
+            <a:schemeClr val="accent1"/>
+          </a:effectRef>
+          <a:fontRef idx="minor">
+            <a:schemeClr val="lt1"/>
+          </a:fontRef>
+        </p:style>
+        <p:txBody>
+          <a:bodyPr rtlCol="0" anchor="ctr" wrap="square"/>
+          <a:lstStyle/>
+          <a:p>
+            <a:pPr algn="ctr"/>
+          </a:p>
+        </p:txBody>
+      </p:sp>
+      <p:sp>
+        <p:nvSpPr>
+          <p:cNvPr id="3" name="TextBox 2"/>
+          <p:cNvSpPr txBox="1"/>
+          <p:nvPr/>
+        </p:nvSpPr>
+        <p:spPr>
+          <a:xfrm>
+            <a:off x="457200" y="146304"/>
+            <a:ext cx="10058400" cy="777240"/>
+          </a:xfrm>
+          <a:prstGeom prst="rect">
+            <a:avLst/>
+          </a:prstGeom>
+          <a:noFill/>
+        </p:spPr>
+        <p:txBody>
+          <a:bodyPr wrap="square" anchor="ctr">
+            <a:spAutoFit/>
+          </a:bodyPr>
+          <a:lstStyle/>
+          <a:p>
+            <a:pPr algn="l"/>
+            <a:r>
+              <a:rPr sz="3400" b="1" i="0">
+                <a:solidFill>
+                  <a:srgbClr val="FFFFFF"/>
+                </a:solidFill>
+                <a:latin typeface="Arial"/>
+              </a:rPr>
+              <a:t>Notebook — Stored Energy</a:t>
+            </a:r>
+          </a:p>
+        </p:txBody>
+      </p:sp>
+      <p:sp>
+        <p:nvSpPr>
+          <p:cNvPr id="4" name="Rounded Rectangle 3"/>
+          <p:cNvSpPr/>
+          <p:nvPr/>
+        </p:nvSpPr>
+        <p:spPr>
+          <a:xfrm>
+            <a:off x="9692640" y="256032"/>
+            <a:ext cx="2103120" cy="548640"/>
+          </a:xfrm>
+          <a:prstGeom prst="roundRect">
+            <a:avLst/>
+          </a:prstGeom>
+          <a:solidFill>
+            <a:srgbClr val="C05014"/>
+          </a:solidFill>
+          <a:ln>
+            <a:noFill/>
+          </a:ln>
+        </p:spPr>
+        <p:style>
+          <a:lnRef idx="1">
+            <a:schemeClr val="accent1"/>
+          </a:lnRef>
+          <a:fillRef idx="3">
+            <a:schemeClr val="accent1"/>
+          </a:fillRef>
+          <a:effectRef idx="2">
+            <a:schemeClr val="accent1"/>
+          </a:effectRef>
+          <a:fontRef idx="minor">
+            <a:schemeClr val="lt1"/>
+          </a:fontRef>
+        </p:style>
+        <p:txBody>
+          <a:bodyPr rtlCol="0" anchor="ctr" wrap="square"/>
+          <a:lstStyle/>
+          <a:p>
+            <a:pPr algn="ctr"/>
+            <a:r>
+              <a:rPr sz="1800" b="1">
+                <a:solidFill>
+                  <a:srgbClr val="FFFFFF"/>
+                </a:solidFill>
+                <a:latin typeface="Arial"/>
+              </a:rPr>
+              <a:t>NOTEBOOK</a:t>
+            </a:r>
+          </a:p>
+        </p:txBody>
+      </p:sp>
+      <p:sp>
+        <p:nvSpPr>
+          <p:cNvPr id="5" name="Rounded Rectangle 4"/>
+          <p:cNvSpPr/>
+          <p:nvPr/>
+        </p:nvSpPr>
+        <p:spPr>
+          <a:xfrm>
+            <a:off x="1097280" y="1737360"/>
+            <a:ext cx="9966960" cy="1234440"/>
+          </a:xfrm>
+          <a:prstGeom prst="roundRect">
+            <a:avLst/>
+          </a:prstGeom>
+          <a:solidFill>
+            <a:srgbClr val="E8EDF4"/>
+          </a:solidFill>
+          <a:ln>
+            <a:noFill/>
+          </a:ln>
+        </p:spPr>
+        <p:style>
+          <a:lnRef idx="1">
+            <a:schemeClr val="accent1"/>
+          </a:lnRef>
+          <a:fillRef idx="3">
+            <a:schemeClr val="accent1"/>
+          </a:fillRef>
+          <a:effectRef idx="2">
+            <a:schemeClr val="accent1"/>
+          </a:effectRef>
+          <a:fontRef idx="minor">
+            <a:schemeClr val="lt1"/>
+          </a:fontRef>
+        </p:style>
+        <p:txBody>
+          <a:bodyPr rtlCol="0" anchor="ctr" wrap="square"/>
+          <a:lstStyle/>
+          <a:p>
+            <a:pPr algn="ctr"/>
+          </a:p>
+        </p:txBody>
+      </p:sp>
+      <p:sp>
+        <p:nvSpPr>
+          <p:cNvPr id="6" name="TextBox 5"/>
+          <p:cNvSpPr txBox="1"/>
+          <p:nvPr/>
+        </p:nvSpPr>
+        <p:spPr>
+          <a:xfrm>
+            <a:off x="1371600" y="1828800"/>
+            <a:ext cx="9418320" cy="457200"/>
+          </a:xfrm>
+          <a:prstGeom prst="rect">
+            <a:avLst/>
+          </a:prstGeom>
+          <a:noFill/>
+        </p:spPr>
+        <p:txBody>
+          <a:bodyPr wrap="square" anchor="t">
+            <a:spAutoFit/>
+          </a:bodyPr>
+          <a:lstStyle/>
+          <a:p>
+            <a:pPr algn="l"/>
+            <a:r>
+              <a:rPr sz="1600" b="1" i="0">
+                <a:solidFill>
+                  <a:srgbClr val="C05014"/>
+                </a:solidFill>
+                <a:latin typeface="Arial"/>
+              </a:rPr>
+              <a:t>WRITE:</a:t>
+            </a:r>
+          </a:p>
+        </p:txBody>
+      </p:sp>
+      <p:sp>
+        <p:nvSpPr>
+          <p:cNvPr id="7" name="TextBox 6"/>
+          <p:cNvSpPr txBox="1"/>
+          <p:nvPr/>
+        </p:nvSpPr>
+        <p:spPr>
+          <a:xfrm>
+            <a:off x="1371600" y="2240280"/>
+            <a:ext cx="9418320" cy="640080"/>
+          </a:xfrm>
+          <a:prstGeom prst="rect">
+            <a:avLst/>
+          </a:prstGeom>
+          <a:noFill/>
+        </p:spPr>
+        <p:txBody>
+          <a:bodyPr wrap="square" anchor="t">
+            <a:spAutoFit/>
+          </a:bodyPr>
+          <a:lstStyle/>
+          <a:p>
+            <a:pPr algn="l"/>
+            <a:r>
+              <a:rPr sz="2800" b="1" i="0">
+                <a:solidFill>
+                  <a:srgbClr val="1F3A5F"/>
+                </a:solidFill>
+                <a:latin typeface="Arial"/>
+              </a:rPr>
+              <a:t>Stored energy can cause a change later.</a:t>
+            </a:r>
+          </a:p>
+        </p:txBody>
+      </p:sp>
+      <p:sp>
+        <p:nvSpPr>
+          <p:cNvPr id="8" name="TextBox 7"/>
+          <p:cNvSpPr txBox="1"/>
+          <p:nvPr/>
+        </p:nvSpPr>
+        <p:spPr>
+          <a:xfrm>
+            <a:off x="1371600" y="3017520"/>
+            <a:ext cx="9418320" cy="457200"/>
+          </a:xfrm>
+          <a:prstGeom prst="rect">
+            <a:avLst/>
+          </a:prstGeom>
+          <a:noFill/>
+        </p:spPr>
+        <p:txBody>
+          <a:bodyPr wrap="square" anchor="t">
+            <a:spAutoFit/>
+          </a:bodyPr>
+          <a:lstStyle/>
+          <a:p>
+            <a:pPr algn="l"/>
+            <a:r>
+              <a:rPr sz="1600" b="0" i="1">
+                <a:solidFill>
+                  <a:srgbClr val="555555"/>
+                </a:solidFill>
+                <a:latin typeface="Arial"/>
+              </a:rPr>
+              <a:t>REVEAL → LATER</a:t>
+            </a:r>
+          </a:p>
+        </p:txBody>
+      </p:sp>
+      <p:sp>
+        <p:nvSpPr>
+          <p:cNvPr id="9" name="Rounded Rectangle 8"/>
+          <p:cNvSpPr/>
+          <p:nvPr/>
+        </p:nvSpPr>
+        <p:spPr>
+          <a:xfrm>
+            <a:off x="1097280" y="4206240"/>
+            <a:ext cx="9966960" cy="1828800"/>
+          </a:xfrm>
+          <a:prstGeom prst="roundRect">
+            <a:avLst/>
+          </a:prstGeom>
+          <a:solidFill>
+            <a:srgbClr val="2E6B3F"/>
+          </a:solidFill>
+          <a:ln>
+            <a:noFill/>
+          </a:ln>
+        </p:spPr>
+        <p:style>
+          <a:lnRef idx="1">
+            <a:schemeClr val="accent1"/>
+          </a:lnRef>
+          <a:fillRef idx="3">
+            <a:schemeClr val="accent1"/>
+          </a:fillRef>
+          <a:effectRef idx="2">
+            <a:schemeClr val="accent1"/>
+          </a:effectRef>
+          <a:fontRef idx="minor">
+            <a:schemeClr val="lt1"/>
+          </a:fontRef>
+        </p:style>
+        <p:txBody>
+          <a:bodyPr rtlCol="0" anchor="ctr" wrap="square"/>
+          <a:lstStyle/>
+          <a:p>
+            <a:pPr algn="ctr"/>
+          </a:p>
+        </p:txBody>
+      </p:sp>
+      <p:sp>
+        <p:nvSpPr>
+          <p:cNvPr id="10" name="TextBox 9"/>
+          <p:cNvSpPr txBox="1"/>
+          <p:nvPr/>
+        </p:nvSpPr>
+        <p:spPr>
+          <a:xfrm>
+            <a:off x="1371600" y="4297679"/>
+            <a:ext cx="9418320" cy="457200"/>
+          </a:xfrm>
+          <a:prstGeom prst="rect">
+            <a:avLst/>
+          </a:prstGeom>
+          <a:noFill/>
+        </p:spPr>
+        <p:txBody>
+          <a:bodyPr wrap="square" anchor="t">
+            <a:spAutoFit/>
+          </a:bodyPr>
+          <a:lstStyle/>
+          <a:p>
+            <a:pPr algn="l"/>
+            <a:r>
+              <a:rPr sz="1600" b="1" i="0">
+                <a:solidFill>
+                  <a:srgbClr val="FFFFFF"/>
+                </a:solidFill>
+                <a:latin typeface="Arial"/>
+              </a:rPr>
+              <a:t>DRAWING IDEAS (draw YOUR example):</a:t>
+            </a:r>
+          </a:p>
+        </p:txBody>
+      </p:sp>
+      <p:sp>
+        <p:nvSpPr>
+          <p:cNvPr id="11" name="TextBox 10"/>
+          <p:cNvSpPr txBox="1"/>
+          <p:nvPr/>
+        </p:nvSpPr>
+        <p:spPr>
+          <a:xfrm>
+            <a:off x="1463040" y="4754879"/>
+            <a:ext cx="9418320" cy="411480"/>
+          </a:xfrm>
+          <a:prstGeom prst="rect">
+            <a:avLst/>
+          </a:prstGeom>
+          <a:noFill/>
+        </p:spPr>
+        <p:txBody>
+          <a:bodyPr wrap="square" anchor="t">
+            <a:spAutoFit/>
+          </a:bodyPr>
+          <a:lstStyle/>
+          <a:p>
+            <a:pPr algn="l"/>
+            <a:r>
+              <a:rPr sz="1800" b="0" i="0">
+                <a:solidFill>
+                  <a:srgbClr val="FFFFFF"/>
+                </a:solidFill>
+                <a:latin typeface="Arial"/>
+              </a:rPr>
+              <a:t>•  a battery in a flashlight</a:t>
+            </a:r>
+          </a:p>
+        </p:txBody>
+      </p:sp>
+      <p:sp>
+        <p:nvSpPr>
+          <p:cNvPr id="12" name="TextBox 11"/>
+          <p:cNvSpPr txBox="1"/>
+          <p:nvPr/>
+        </p:nvSpPr>
+        <p:spPr>
+          <a:xfrm>
+            <a:off x="1463040" y="5166359"/>
+            <a:ext cx="9418320" cy="411480"/>
+          </a:xfrm>
+          <a:prstGeom prst="rect">
+            <a:avLst/>
+          </a:prstGeom>
+          <a:noFill/>
+        </p:spPr>
+        <p:txBody>
+          <a:bodyPr wrap="square" anchor="t">
+            <a:spAutoFit/>
+          </a:bodyPr>
+          <a:lstStyle/>
+          <a:p>
+            <a:pPr algn="l"/>
+            <a:r>
+              <a:rPr sz="1800" b="0" i="0">
+                <a:solidFill>
+                  <a:srgbClr val="FFFFFF"/>
+                </a:solidFill>
+                <a:latin typeface="Arial"/>
+              </a:rPr>
+              <a:t>•  a stretched rubber band</a:t>
+            </a:r>
+          </a:p>
+        </p:txBody>
+      </p:sp>
+      <p:sp>
+        <p:nvSpPr>
+          <p:cNvPr id="13" name="TextBox 12"/>
+          <p:cNvSpPr txBox="1"/>
+          <p:nvPr/>
+        </p:nvSpPr>
+        <p:spPr>
+          <a:xfrm>
+            <a:off x="1463040" y="5577840"/>
+            <a:ext cx="9418320" cy="411480"/>
+          </a:xfrm>
+          <a:prstGeom prst="rect">
+            <a:avLst/>
+          </a:prstGeom>
+          <a:noFill/>
+        </p:spPr>
+        <p:txBody>
+          <a:bodyPr wrap="square" anchor="t">
+            <a:spAutoFit/>
+          </a:bodyPr>
+          <a:lstStyle/>
+          <a:p>
+            <a:pPr algn="l"/>
+            <a:r>
+              <a:rPr sz="1800" b="0" i="0">
+                <a:solidFill>
+                  <a:srgbClr val="FFFFFF"/>
+                </a:solidFill>
+                <a:latin typeface="Arial"/>
+              </a:rPr>
+              <a:t>•  a raised object (apple/book)</a:t>
             </a:r>
           </a:p>
         </p:txBody>

</xml_diff>